<commit_message>
Dormeo US weekly deck: cover logo without white box, no data-source line, no Read-out panels
Co-Authored-By: Claude Opus 5.5 <noreply@anthropic.com>
Claude-Session: https://claude.ai/code/session_01RHhJWYgzkcDa1EG1ieFn7V
</commit_message>
<xml_diff>
--- a/dormeo-us/deck/2026-10-24/Dormeo-US-Weekly-Business-Review-Week-43-2026-10-24.pptx
+++ b/dormeo-us/deck/2026-10-24/Dormeo-US-Weekly-Business-Review-Week-43-2026-10-24.pptx
@@ -772,33 +772,9 @@
           </a:ln>
         </p:spPr>
       </p:sp>
-      <p:sp>
-        <p:nvSpPr>
-          <p:cNvPr id="4" name=""/>
-          <p:cNvSpPr/>
-          <p:nvPr/>
-        </p:nvSpPr>
-        <p:spPr>
-          <a:xfrm>
-            <a:off x="822960" y="640080"/>
-            <a:ext cx="2743200" cy="685800"/>
-          </a:xfrm>
-          <a:prstGeom prst="roundRect">
-            <a:avLst>
-              <a:gd name="" fmla="val 6000"/>
-            </a:avLst>
-          </a:prstGeom>
-          <a:solidFill>
-            <a:srgbClr val="FFFFFF"/>
-          </a:solidFill>
-          <a:ln>
-            <a:noFill/>
-          </a:ln>
-        </p:spPr>
-      </p:sp>
       <p:pic>
         <p:nvPicPr>
-          <p:cNvPr id="5" name="" descr="logo_s.png"/>
+          <p:cNvPr id="4" name="" descr="logo_dark_s.png"/>
           <p:cNvPicPr>
             <a:picLocks noChangeAspect="1"/>
           </p:cNvPicPr>
@@ -812,8 +788,8 @@
         </p:blipFill>
         <p:spPr>
           <a:xfrm>
-            <a:off x="1005840" y="749808"/>
-            <a:ext cx="2377440" cy="416052"/>
+            <a:off x="822960" y="777240"/>
+            <a:ext cx="2560320" cy="312928"/>
           </a:xfrm>
           <a:prstGeom prst="rect">
             <a:avLst/>
@@ -822,7 +798,7 @@
       </p:pic>
       <p:sp>
         <p:nvSpPr>
-          <p:cNvPr id="6" name=""/>
+          <p:cNvPr id="5" name=""/>
           <p:cNvSpPr txBox="1"/>
           <p:nvPr/>
         </p:nvSpPr>
@@ -857,7 +833,7 @@
       </p:sp>
       <p:sp>
         <p:nvSpPr>
-          <p:cNvPr id="7" name=""/>
+          <p:cNvPr id="6" name=""/>
           <p:cNvSpPr txBox="1"/>
           <p:nvPr/>
         </p:nvSpPr>
@@ -892,7 +868,7 @@
       </p:sp>
       <p:sp>
         <p:nvSpPr>
-          <p:cNvPr id="8" name=""/>
+          <p:cNvPr id="7" name=""/>
           <p:cNvSpPr txBox="1"/>
           <p:nvPr/>
         </p:nvSpPr>
@@ -927,7 +903,7 @@
       </p:sp>
       <p:sp>
         <p:nvSpPr>
-          <p:cNvPr id="9" name=""/>
+          <p:cNvPr id="8" name=""/>
           <p:cNvSpPr txBox="1"/>
           <p:nvPr/>
         </p:nvSpPr>
@@ -956,63 +932,6 @@
                 <a:latin typeface="Inter"/>
               </a:rPr>
               <a:t>Week ending Saturday, October 24, 2026  ·  Oct 18–24, 2026</a:t>
-            </a:r>
-          </a:p>
-        </p:txBody>
-      </p:sp>
-      <p:sp>
-        <p:nvSpPr>
-          <p:cNvPr id="10" name=""/>
-          <p:cNvSpPr/>
-          <p:nvPr/>
-        </p:nvSpPr>
-        <p:spPr>
-          <a:xfrm>
-            <a:off x="822960" y="5623560"/>
-            <a:ext cx="10515600" cy="9144"/>
-          </a:xfrm>
-          <a:prstGeom prst="rect">
-            <a:avLst/>
-          </a:prstGeom>
-          <a:solidFill>
-            <a:srgbClr val="334155"/>
-          </a:solidFill>
-          <a:ln>
-            <a:noFill/>
-          </a:ln>
-        </p:spPr>
-      </p:sp>
-      <p:sp>
-        <p:nvSpPr>
-          <p:cNvPr id="11" name=""/>
-          <p:cNvSpPr txBox="1"/>
-          <p:nvPr/>
-        </p:nvSpPr>
-        <p:spPr>
-          <a:xfrm>
-            <a:off x="822960" y="5760720"/>
-            <a:ext cx="7315200" cy="365760"/>
-          </a:xfrm>
-          <a:prstGeom prst="rect">
-            <a:avLst/>
-          </a:prstGeom>
-          <a:noFill/>
-        </p:spPr>
-        <p:txBody>
-          <a:bodyPr wrap="square" lIns="36576" rIns="36576" tIns="18288" bIns="18288" anchor="t">
-            <a:spAutoFit/>
-          </a:bodyPr>
-          <a:lstStyle/>
-          <a:p>
-            <a:pPr algn="l"/>
-            <a:r>
-              <a:rPr sz="1100" b="0">
-                <a:solidFill>
-                  <a:srgbClr val="94A3B8"/>
-                </a:solidFill>
-                <a:latin typeface="Inter"/>
-              </a:rPr>
-              <a:t>Prepared by Flagship Growth  ·  Data: Sellerise (Amazon US) and the Dormeo inventory tracker</a:t>
             </a:r>
           </a:p>
         </p:txBody>
@@ -7393,7 +7312,7 @@
         <p:spPr>
           <a:xfrm>
             <a:off x="3429000" y="1371600"/>
-            <a:ext cx="4754880" cy="274320"/>
+            <a:ext cx="8211312" cy="274320"/>
           </a:xfrm>
           <a:prstGeom prst="rect">
             <a:avLst/>
@@ -7555,7 +7474,7 @@
         <p:spPr>
           <a:xfrm>
             <a:off x="5257800" y="2374925"/>
-            <a:ext cx="268224" cy="313639"/>
+            <a:ext cx="729081" cy="313639"/>
           </a:xfrm>
           <a:prstGeom prst="rect">
             <a:avLst/>
@@ -7576,7 +7495,7 @@
         </p:nvSpPr>
         <p:spPr>
           <a:xfrm>
-            <a:off x="5580887" y="2251710"/>
+            <a:off x="6041745" y="2251710"/>
             <a:ext cx="914400" cy="560070"/>
           </a:xfrm>
           <a:prstGeom prst="rect">
@@ -7647,7 +7566,7 @@
         <p:spPr>
           <a:xfrm>
             <a:off x="5257800" y="2934995"/>
-            <a:ext cx="663575" cy="313639"/>
+            <a:ext cx="1803717" cy="313639"/>
           </a:xfrm>
           <a:prstGeom prst="rect">
             <a:avLst/>
@@ -7668,7 +7587,7 @@
         </p:nvSpPr>
         <p:spPr>
           <a:xfrm>
-            <a:off x="5976239" y="2811780"/>
+            <a:off x="7116381" y="2811780"/>
             <a:ext cx="914400" cy="560070"/>
           </a:xfrm>
           <a:prstGeom prst="rect">
@@ -7739,7 +7658,7 @@
         <p:spPr>
           <a:xfrm>
             <a:off x="5257800" y="3495065"/>
-            <a:ext cx="907228" cy="313639"/>
+            <a:ext cx="2466011" cy="313639"/>
           </a:xfrm>
           <a:prstGeom prst="rect">
             <a:avLst/>
@@ -7760,7 +7679,7 @@
         </p:nvSpPr>
         <p:spPr>
           <a:xfrm>
-            <a:off x="6219892" y="3371850"/>
+            <a:off x="7778675" y="3371850"/>
             <a:ext cx="914400" cy="560070"/>
           </a:xfrm>
           <a:prstGeom prst="rect">
@@ -7831,7 +7750,7 @@
         <p:spPr>
           <a:xfrm>
             <a:off x="5257800" y="4055135"/>
-            <a:ext cx="458216" cy="313639"/>
+            <a:ext cx="1245514" cy="313639"/>
           </a:xfrm>
           <a:prstGeom prst="rect">
             <a:avLst/>
@@ -7852,7 +7771,7 @@
         </p:nvSpPr>
         <p:spPr>
           <a:xfrm>
-            <a:off x="5770880" y="3931920"/>
+            <a:off x="6558178" y="3931920"/>
             <a:ext cx="914400" cy="560070"/>
           </a:xfrm>
           <a:prstGeom prst="rect">
@@ -7923,7 +7842,7 @@
         <p:spPr>
           <a:xfrm>
             <a:off x="5257800" y="4615205"/>
-            <a:ext cx="886097" cy="313639"/>
+            <a:ext cx="2408573" cy="313639"/>
           </a:xfrm>
           <a:prstGeom prst="rect">
             <a:avLst/>
@@ -7944,7 +7863,7 @@
         </p:nvSpPr>
         <p:spPr>
           <a:xfrm>
-            <a:off x="6198761" y="4491990"/>
+            <a:off x="7721237" y="4491990"/>
             <a:ext cx="914400" cy="560070"/>
           </a:xfrm>
           <a:prstGeom prst="rect">
@@ -8015,7 +7934,7 @@
         <p:spPr>
           <a:xfrm>
             <a:off x="5257800" y="5175275"/>
-            <a:ext cx="387667" cy="313639"/>
+            <a:ext cx="1053750" cy="313639"/>
           </a:xfrm>
           <a:prstGeom prst="rect">
             <a:avLst/>
@@ -8036,7 +7955,7 @@
         </p:nvSpPr>
         <p:spPr>
           <a:xfrm>
-            <a:off x="5700331" y="5052060"/>
+            <a:off x="6366414" y="5052060"/>
             <a:ext cx="914400" cy="560070"/>
           </a:xfrm>
           <a:prstGeom prst="rect">
@@ -8107,7 +8026,7 @@
         <p:spPr>
           <a:xfrm>
             <a:off x="5257800" y="5735345"/>
-            <a:ext cx="2011680" cy="313639"/>
+            <a:ext cx="5468112" cy="313639"/>
           </a:xfrm>
           <a:prstGeom prst="rect">
             <a:avLst/>
@@ -8128,7 +8047,7 @@
         </p:nvSpPr>
         <p:spPr>
           <a:xfrm>
-            <a:off x="7324344" y="5612130"/>
+            <a:off x="10780776" y="5612130"/>
             <a:ext cx="914400" cy="560070"/>
           </a:xfrm>
           <a:prstGeom prst="rect">
@@ -8151,138 +8070,6 @@
                 <a:latin typeface="Inter"/>
               </a:rPr>
               <a:t>12+ wk</a:t>
-            </a:r>
-          </a:p>
-        </p:txBody>
-      </p:sp>
-      <p:sp>
-        <p:nvSpPr>
-          <p:cNvPr id="47" name=""/>
-          <p:cNvSpPr/>
-          <p:nvPr/>
-        </p:nvSpPr>
-        <p:spPr>
-          <a:xfrm>
-            <a:off x="8366760" y="1371600"/>
-            <a:ext cx="3273552" cy="4846320"/>
-          </a:xfrm>
-          <a:prstGeom prst="roundRect">
-            <a:avLst>
-              <a:gd name="" fmla="val 6000"/>
-            </a:avLst>
-          </a:prstGeom>
-          <a:solidFill>
-            <a:srgbClr val="FFFFFF"/>
-          </a:solidFill>
-          <a:ln w="9525">
-            <a:solidFill>
-              <a:srgbClr val="E5E0D6"/>
-            </a:solidFill>
-          </a:ln>
-        </p:spPr>
-      </p:sp>
-      <p:sp>
-        <p:nvSpPr>
-          <p:cNvPr id="48" name=""/>
-          <p:cNvSpPr txBox="1"/>
-          <p:nvPr/>
-        </p:nvSpPr>
-        <p:spPr>
-          <a:xfrm>
-            <a:off x="8549640" y="1508760"/>
-            <a:ext cx="2907792" cy="274320"/>
-          </a:xfrm>
-          <a:prstGeom prst="rect">
-            <a:avLst/>
-          </a:prstGeom>
-          <a:noFill/>
-        </p:spPr>
-        <p:txBody>
-          <a:bodyPr wrap="square" lIns="36576" rIns="36576" tIns="18288" bIns="18288" anchor="t">
-            <a:spAutoFit/>
-          </a:bodyPr>
-          <a:lstStyle/>
-          <a:p>
-            <a:pPr algn="l"/>
-            <a:r>
-              <a:rPr sz="1200" b="1">
-                <a:solidFill>
-                  <a:srgbClr val="0F172A"/>
-                </a:solidFill>
-                <a:latin typeface="Space Grotesk"/>
-              </a:rPr>
-              <a:t>Read-out</a:t>
-            </a:r>
-          </a:p>
-        </p:txBody>
-      </p:sp>
-      <p:sp>
-        <p:nvSpPr>
-          <p:cNvPr id="49" name=""/>
-          <p:cNvSpPr txBox="1"/>
-          <p:nvPr/>
-        </p:nvSpPr>
-        <p:spPr>
-          <a:xfrm>
-            <a:off x="8549640" y="1828800"/>
-            <a:ext cx="2907792" cy="4297680"/>
-          </a:xfrm>
-          <a:prstGeom prst="rect">
-            <a:avLst/>
-          </a:prstGeom>
-          <a:noFill/>
-        </p:spPr>
-        <p:txBody>
-          <a:bodyPr wrap="square" lIns="36576" rIns="36576" tIns="18288" bIns="18288" anchor="t">
-            <a:spAutoFit/>
-          </a:bodyPr>
-          <a:lstStyle/>
-          <a:p>
-            <a:pPr algn="l">
-              <a:spcAft>
-                <a:spcPts val="500"/>
-              </a:spcAft>
-            </a:pPr>
-            <a:r>
-              <a:rPr sz="1050" b="0">
-                <a:solidFill>
-                  <a:srgbClr val="334155"/>
-                </a:solidFill>
-                <a:latin typeface="Inter"/>
-              </a:rPr>
-              <a:t>Octaspring Queen: 0 available, 400 inbound, ~100 sold per week. Its 30-day sales were $152,600, so every week out costs real revenue.</a:t>
-            </a:r>
-          </a:p>
-          <a:p>
-            <a:pPr algn="l">
-              <a:spcAft>
-                <a:spcPts val="500"/>
-              </a:spcAft>
-            </a:pPr>
-            <a:r>
-              <a:rPr sz="1050" b="0">
-                <a:solidFill>
-                  <a:srgbClr val="334155"/>
-                </a:solidFill>
-                <a:latin typeface="Inter"/>
-              </a:rPr>
-              <a:t>Octaspring King is next: about 1.6 weeks available at FBA with 227 inbound.</a:t>
-            </a:r>
-          </a:p>
-          <a:p>
-            <a:pPr algn="l">
-              <a:spcAft>
-                <a:spcPts val="500"/>
-              </a:spcAft>
-            </a:pPr>
-            <a:r>
-              <a:rPr sz="1050" b="0">
-                <a:solidFill>
-                  <a:srgbClr val="334155"/>
-                </a:solidFill>
-                <a:latin typeface="Inter"/>
-              </a:rPr>
-              <a:t>Premium Cal King is down to 1 unit.</a:t>
             </a:r>
           </a:p>
         </p:txBody>
@@ -9444,7 +9231,7 @@
         <p:spPr>
           <a:xfrm>
             <a:off x="3429000" y="1371600"/>
-            <a:ext cx="4754880" cy="274320"/>
+            <a:ext cx="8211312" cy="274320"/>
           </a:xfrm>
           <a:prstGeom prst="rect">
             <a:avLst/>
@@ -9514,7 +9301,7 @@
         <p:spPr>
           <a:xfrm>
             <a:off x="5257800" y="1790212"/>
-            <a:ext cx="2011680" cy="250911"/>
+            <a:ext cx="5468112" cy="250911"/>
           </a:xfrm>
           <a:prstGeom prst="rect">
             <a:avLst/>
@@ -9535,7 +9322,7 @@
         </p:nvSpPr>
         <p:spPr>
           <a:xfrm>
-            <a:off x="7324344" y="1691640"/>
+            <a:off x="10780776" y="1691640"/>
             <a:ext cx="914400" cy="448056"/>
           </a:xfrm>
           <a:prstGeom prst="rect">
@@ -9606,7 +9393,7 @@
         <p:spPr>
           <a:xfrm>
             <a:off x="5257800" y="2238268"/>
-            <a:ext cx="750117" cy="250911"/>
+            <a:ext cx="2038957" cy="250911"/>
           </a:xfrm>
           <a:prstGeom prst="rect">
             <a:avLst/>
@@ -9627,7 +9414,7 @@
         </p:nvSpPr>
         <p:spPr>
           <a:xfrm>
-            <a:off x="6062781" y="2139696"/>
+            <a:off x="7351621" y="2139696"/>
             <a:ext cx="914400" cy="448056"/>
           </a:xfrm>
           <a:prstGeom prst="rect">
@@ -9698,7 +9485,7 @@
         <p:spPr>
           <a:xfrm>
             <a:off x="5257800" y="2686324"/>
-            <a:ext cx="409155" cy="250911"/>
+            <a:ext cx="1112158" cy="250911"/>
           </a:xfrm>
           <a:prstGeom prst="rect">
             <a:avLst/>
@@ -9719,7 +9506,7 @@
         </p:nvSpPr>
         <p:spPr>
           <a:xfrm>
-            <a:off x="5721819" y="2587752"/>
+            <a:off x="6424822" y="2587752"/>
             <a:ext cx="914400" cy="448056"/>
           </a:xfrm>
           <a:prstGeom prst="rect">
@@ -9790,7 +9577,7 @@
         <p:spPr>
           <a:xfrm>
             <a:off x="5257800" y="3134380"/>
-            <a:ext cx="187529" cy="250911"/>
+            <a:ext cx="509739" cy="250911"/>
           </a:xfrm>
           <a:prstGeom prst="rect">
             <a:avLst/>
@@ -9811,7 +9598,7 @@
         </p:nvSpPr>
         <p:spPr>
           <a:xfrm>
-            <a:off x="5500193" y="3035808"/>
+            <a:off x="5822403" y="3035808"/>
             <a:ext cx="914400" cy="448056"/>
           </a:xfrm>
           <a:prstGeom prst="rect">
@@ -9882,7 +9669,7 @@
         <p:spPr>
           <a:xfrm>
             <a:off x="5257800" y="3582436"/>
-            <a:ext cx="170481" cy="250911"/>
+            <a:ext cx="463399" cy="250911"/>
           </a:xfrm>
           <a:prstGeom prst="rect">
             <a:avLst/>
@@ -9903,7 +9690,7 @@
         </p:nvSpPr>
         <p:spPr>
           <a:xfrm>
-            <a:off x="5483145" y="3483864"/>
+            <a:off x="5776063" y="3483864"/>
             <a:ext cx="914400" cy="448056"/>
           </a:xfrm>
           <a:prstGeom prst="rect">
@@ -9974,7 +9761,7 @@
         <p:spPr>
           <a:xfrm>
             <a:off x="5257800" y="4030492"/>
-            <a:ext cx="170481" cy="250911"/>
+            <a:ext cx="463399" cy="250911"/>
           </a:xfrm>
           <a:prstGeom prst="rect">
             <a:avLst/>
@@ -9995,7 +9782,7 @@
         </p:nvSpPr>
         <p:spPr>
           <a:xfrm>
-            <a:off x="5483145" y="3931920"/>
+            <a:off x="5776063" y="3931920"/>
             <a:ext cx="914400" cy="448056"/>
           </a:xfrm>
           <a:prstGeom prst="rect">
@@ -10066,7 +9853,7 @@
         <p:spPr>
           <a:xfrm>
             <a:off x="5257800" y="4478548"/>
-            <a:ext cx="153433" cy="250911"/>
+            <a:ext cx="417059" cy="250911"/>
           </a:xfrm>
           <a:prstGeom prst="rect">
             <a:avLst/>
@@ -10087,7 +9874,7 @@
         </p:nvSpPr>
         <p:spPr>
           <a:xfrm>
-            <a:off x="5466097" y="4379976"/>
+            <a:off x="5729723" y="4379976"/>
             <a:ext cx="914400" cy="448056"/>
           </a:xfrm>
           <a:prstGeom prst="rect">
@@ -10158,7 +9945,7 @@
         <p:spPr>
           <a:xfrm>
             <a:off x="5257800" y="4926604"/>
-            <a:ext cx="136385" cy="250911"/>
+            <a:ext cx="370719" cy="250911"/>
           </a:xfrm>
           <a:prstGeom prst="rect">
             <a:avLst/>
@@ -10179,7 +9966,7 @@
         </p:nvSpPr>
         <p:spPr>
           <a:xfrm>
-            <a:off x="5449049" y="4828032"/>
+            <a:off x="5683383" y="4828032"/>
             <a:ext cx="914400" cy="448056"/>
           </a:xfrm>
           <a:prstGeom prst="rect">
@@ -10250,7 +10037,7 @@
         <p:spPr>
           <a:xfrm>
             <a:off x="5257800" y="5374660"/>
-            <a:ext cx="85240" cy="250911"/>
+            <a:ext cx="231699" cy="250911"/>
           </a:xfrm>
           <a:prstGeom prst="rect">
             <a:avLst/>
@@ -10271,7 +10058,7 @@
         </p:nvSpPr>
         <p:spPr>
           <a:xfrm>
-            <a:off x="5397904" y="5276088"/>
+            <a:off x="5544363" y="5276088"/>
             <a:ext cx="914400" cy="448056"/>
           </a:xfrm>
           <a:prstGeom prst="rect">
@@ -10342,7 +10129,7 @@
         <p:spPr>
           <a:xfrm>
             <a:off x="5257800" y="5822716"/>
-            <a:ext cx="85240" cy="250911"/>
+            <a:ext cx="231699" cy="250911"/>
           </a:xfrm>
           <a:prstGeom prst="rect">
             <a:avLst/>
@@ -10363,7 +10150,7 @@
         </p:nvSpPr>
         <p:spPr>
           <a:xfrm>
-            <a:off x="5397904" y="5724144"/>
+            <a:off x="5544363" y="5724144"/>
             <a:ext cx="914400" cy="448056"/>
           </a:xfrm>
           <a:prstGeom prst="rect">
@@ -10386,138 +10173,6 @@
                 <a:latin typeface="Inter"/>
               </a:rPr>
               <a:t>5</a:t>
-            </a:r>
-          </a:p>
-        </p:txBody>
-      </p:sp>
-      <p:sp>
-        <p:nvSpPr>
-          <p:cNvPr id="53" name=""/>
-          <p:cNvSpPr/>
-          <p:nvPr/>
-        </p:nvSpPr>
-        <p:spPr>
-          <a:xfrm>
-            <a:off x="8366760" y="1371600"/>
-            <a:ext cx="3273552" cy="4846320"/>
-          </a:xfrm>
-          <a:prstGeom prst="roundRect">
-            <a:avLst>
-              <a:gd name="" fmla="val 6000"/>
-            </a:avLst>
-          </a:prstGeom>
-          <a:solidFill>
-            <a:srgbClr val="FFFFFF"/>
-          </a:solidFill>
-          <a:ln w="9525">
-            <a:solidFill>
-              <a:srgbClr val="E5E0D6"/>
-            </a:solidFill>
-          </a:ln>
-        </p:spPr>
-      </p:sp>
-      <p:sp>
-        <p:nvSpPr>
-          <p:cNvPr id="54" name=""/>
-          <p:cNvSpPr txBox="1"/>
-          <p:nvPr/>
-        </p:nvSpPr>
-        <p:spPr>
-          <a:xfrm>
-            <a:off x="8549640" y="1508760"/>
-            <a:ext cx="2907792" cy="274320"/>
-          </a:xfrm>
-          <a:prstGeom prst="rect">
-            <a:avLst/>
-          </a:prstGeom>
-          <a:noFill/>
-        </p:spPr>
-        <p:txBody>
-          <a:bodyPr wrap="square" lIns="36576" rIns="36576" tIns="18288" bIns="18288" anchor="t">
-            <a:spAutoFit/>
-          </a:bodyPr>
-          <a:lstStyle/>
-          <a:p>
-            <a:pPr algn="l"/>
-            <a:r>
-              <a:rPr sz="1200" b="1">
-                <a:solidFill>
-                  <a:srgbClr val="0F172A"/>
-                </a:solidFill>
-                <a:latin typeface="Space Grotesk"/>
-              </a:rPr>
-              <a:t>Read-out</a:t>
-            </a:r>
-          </a:p>
-        </p:txBody>
-      </p:sp>
-      <p:sp>
-        <p:nvSpPr>
-          <p:cNvPr id="55" name=""/>
-          <p:cNvSpPr txBox="1"/>
-          <p:nvPr/>
-        </p:nvSpPr>
-        <p:spPr>
-          <a:xfrm>
-            <a:off x="8549640" y="1828800"/>
-            <a:ext cx="2907792" cy="4297680"/>
-          </a:xfrm>
-          <a:prstGeom prst="rect">
-            <a:avLst/>
-          </a:prstGeom>
-          <a:noFill/>
-        </p:spPr>
-        <p:txBody>
-          <a:bodyPr wrap="square" lIns="36576" rIns="36576" tIns="18288" bIns="18288" anchor="t">
-            <a:spAutoFit/>
-          </a:bodyPr>
-          <a:lstStyle/>
-          <a:p>
-            <a:pPr algn="l">
-              <a:spcAft>
-                <a:spcPts val="500"/>
-              </a:spcAft>
-            </a:pPr>
-            <a:r>
-              <a:rPr sz="1050" b="0">
-                <a:solidFill>
-                  <a:srgbClr val="334155"/>
-                </a:solidFill>
-                <a:latin typeface="Inter"/>
-              </a:rPr>
-              <a:t>Most alerts are routine listing changes (images, price, title).</a:t>
-            </a:r>
-          </a:p>
-          <a:p>
-            <a:pPr algn="l">
-              <a:spcAft>
-                <a:spcPts val="500"/>
-              </a:spcAft>
-            </a:pPr>
-            <a:r>
-              <a:rPr sz="1050" b="0">
-                <a:solidFill>
-                  <a:srgbClr val="334155"/>
-                </a:solidFill>
-                <a:latin typeface="Inter"/>
-              </a:rPr>
-              <a:t>Buy Box: lost 10 times and regained 10 times. The latest Buy Box alert (Oct 26) is on the Premium Queen topper, the out-of-stock ASIN.</a:t>
-            </a:r>
-          </a:p>
-          <a:p>
-            <a:pPr algn="l">
-              <a:spcAft>
-                <a:spcPts val="500"/>
-              </a:spcAft>
-            </a:pPr>
-            <a:r>
-              <a:rPr sz="1050" b="0">
-                <a:solidFill>
-                  <a:srgbClr val="334155"/>
-                </a:solidFill>
-                <a:latin typeface="Inter"/>
-              </a:rPr>
-              <a:t>11 inactive and 5 out-of-stock alerts line up with the inventory gaps on the previous slide.</a:t>
             </a:r>
           </a:p>
         </p:txBody>
@@ -25684,7 +25339,7 @@
         </p:nvGraphicFramePr>
         <p:xfrm>
           <a:off x="548640" y="1417320"/>
-          <a:ext cx="6766560" cy="2084832"/>
+          <a:ext cx="11091672" cy="2304288"/>
         </p:xfrm>
         <a:graphic>
           <a:graphicData uri="http://schemas.openxmlformats.org/drawingml/2006/table">
@@ -25693,15 +25348,15 @@
                 <a:tableStyleId>{5C22544A-7EE6-4342-B048-85BDC9FD1C3A}</a:tableStyleId>
               </a:tblPr>
               <a:tblGrid>
-                <a:gridCol w="2651760"/>
-                <a:gridCol w="548640"/>
-                <a:gridCol w="1005840"/>
-                <a:gridCol w="640080"/>
-                <a:gridCol w="640080"/>
-                <a:gridCol w="640080"/>
-                <a:gridCol w="640080"/>
+                <a:gridCol w="4325112"/>
+                <a:gridCol w="914400"/>
+                <a:gridCol w="1463040"/>
+                <a:gridCol w="1097280"/>
+                <a:gridCol w="1097280"/>
+                <a:gridCol w="1097280"/>
+                <a:gridCol w="1097280"/>
               </a:tblGrid>
-              <a:tr h="347472">
+              <a:tr h="384048">
                 <a:tc>
                   <a:txBody>
                     <a:bodyPr wrap="square"/>
@@ -25709,7 +25364,7 @@
                     <a:p>
                       <a:pPr algn="l"/>
                       <a:r>
-                        <a:rPr sz="950" b="1">
+                        <a:rPr sz="1000" b="1">
                           <a:solidFill>
                             <a:srgbClr val="FFFFFF"/>
                           </a:solidFill>
@@ -25732,7 +25387,7 @@
                     <a:p>
                       <a:pPr algn="r"/>
                       <a:r>
-                        <a:rPr sz="950" b="1">
+                        <a:rPr sz="1000" b="1">
                           <a:solidFill>
                             <a:srgbClr val="FFFFFF"/>
                           </a:solidFill>
@@ -25755,7 +25410,7 @@
                     <a:p>
                       <a:pPr algn="r"/>
                       <a:r>
-                        <a:rPr sz="950" b="1">
+                        <a:rPr sz="1000" b="1">
                           <a:solidFill>
                             <a:srgbClr val="FFFFFF"/>
                           </a:solidFill>
@@ -25778,7 +25433,7 @@
                     <a:p>
                       <a:pPr algn="r"/>
                       <a:r>
-                        <a:rPr sz="950" b="1">
+                        <a:rPr sz="1000" b="1">
                           <a:solidFill>
                             <a:srgbClr val="FFFFFF"/>
                           </a:solidFill>
@@ -25801,7 +25456,7 @@
                     <a:p>
                       <a:pPr algn="r"/>
                       <a:r>
-                        <a:rPr sz="950" b="1">
+                        <a:rPr sz="1000" b="1">
                           <a:solidFill>
                             <a:srgbClr val="FFFFFF"/>
                           </a:solidFill>
@@ -25824,7 +25479,7 @@
                     <a:p>
                       <a:pPr algn="r"/>
                       <a:r>
-                        <a:rPr sz="950" b="1">
+                        <a:rPr sz="1000" b="1">
                           <a:solidFill>
                             <a:srgbClr val="FFFFFF"/>
                           </a:solidFill>
@@ -25847,7 +25502,7 @@
                     <a:p>
                       <a:pPr algn="r"/>
                       <a:r>
-                        <a:rPr sz="950" b="1">
+                        <a:rPr sz="1000" b="1">
                           <a:solidFill>
                             <a:srgbClr val="FFFFFF"/>
                           </a:solidFill>
@@ -25864,7 +25519,7 @@
                   </a:tcPr>
                 </a:tc>
               </a:tr>
-              <a:tr h="347472">
+              <a:tr h="384048">
                 <a:tc>
                   <a:txBody>
                     <a:bodyPr wrap="square"/>
@@ -25872,7 +25527,7 @@
                     <a:p>
                       <a:pPr algn="l"/>
                       <a:r>
-                        <a:rPr sz="1050" b="0">
+                        <a:rPr sz="1100" b="0">
                           <a:solidFill>
                             <a:srgbClr val="0F172A"/>
                           </a:solidFill>
@@ -25895,7 +25550,7 @@
                     <a:p>
                       <a:pPr algn="r"/>
                       <a:r>
-                        <a:rPr sz="1050" b="0">
+                        <a:rPr sz="1100" b="0">
                           <a:solidFill>
                             <a:srgbClr val="0F172A"/>
                           </a:solidFill>
@@ -25918,7 +25573,7 @@
                     <a:p>
                       <a:pPr algn="r"/>
                       <a:r>
-                        <a:rPr sz="1050" b="0">
+                        <a:rPr sz="1100" b="0">
                           <a:solidFill>
                             <a:srgbClr val="0F172A"/>
                           </a:solidFill>
@@ -25941,7 +25596,7 @@
                     <a:p>
                       <a:pPr algn="r"/>
                       <a:r>
-                        <a:rPr sz="1050" b="0">
+                        <a:rPr sz="1100" b="0">
                           <a:solidFill>
                             <a:srgbClr val="0F172A"/>
                           </a:solidFill>
@@ -25964,7 +25619,7 @@
                     <a:p>
                       <a:pPr algn="r"/>
                       <a:r>
-                        <a:rPr sz="1050" b="0">
+                        <a:rPr sz="1100" b="0">
                           <a:solidFill>
                             <a:srgbClr val="0F172A"/>
                           </a:solidFill>
@@ -25987,7 +25642,7 @@
                     <a:p>
                       <a:pPr algn="r"/>
                       <a:r>
-                        <a:rPr sz="1050" b="0">
+                        <a:rPr sz="1100" b="0">
                           <a:solidFill>
                             <a:srgbClr val="0F172A"/>
                           </a:solidFill>
@@ -26010,7 +25665,7 @@
                     <a:p>
                       <a:pPr algn="r"/>
                       <a:r>
-                        <a:rPr sz="1050" b="0">
+                        <a:rPr sz="1100" b="0">
                           <a:solidFill>
                             <a:srgbClr val="0F172A"/>
                           </a:solidFill>
@@ -26027,7 +25682,7 @@
                   </a:tcPr>
                 </a:tc>
               </a:tr>
-              <a:tr h="347472">
+              <a:tr h="384048">
                 <a:tc>
                   <a:txBody>
                     <a:bodyPr wrap="square"/>
@@ -26035,7 +25690,7 @@
                     <a:p>
                       <a:pPr algn="l"/>
                       <a:r>
-                        <a:rPr sz="1050" b="0">
+                        <a:rPr sz="1100" b="0">
                           <a:solidFill>
                             <a:srgbClr val="0F172A"/>
                           </a:solidFill>
@@ -26058,7 +25713,7 @@
                     <a:p>
                       <a:pPr algn="r"/>
                       <a:r>
-                        <a:rPr sz="1050" b="0">
+                        <a:rPr sz="1100" b="0">
                           <a:solidFill>
                             <a:srgbClr val="0F172A"/>
                           </a:solidFill>
@@ -26081,7 +25736,7 @@
                     <a:p>
                       <a:pPr algn="r"/>
                       <a:r>
-                        <a:rPr sz="1050" b="0">
+                        <a:rPr sz="1100" b="0">
                           <a:solidFill>
                             <a:srgbClr val="0F172A"/>
                           </a:solidFill>
@@ -26104,7 +25759,7 @@
                     <a:p>
                       <a:pPr algn="r"/>
                       <a:r>
-                        <a:rPr sz="1050" b="0">
+                        <a:rPr sz="1100" b="0">
                           <a:solidFill>
                             <a:srgbClr val="0F172A"/>
                           </a:solidFill>
@@ -26127,7 +25782,7 @@
                     <a:p>
                       <a:pPr algn="r"/>
                       <a:r>
-                        <a:rPr sz="1050" b="0">
+                        <a:rPr sz="1100" b="0">
                           <a:solidFill>
                             <a:srgbClr val="0F172A"/>
                           </a:solidFill>
@@ -26150,7 +25805,7 @@
                     <a:p>
                       <a:pPr algn="r"/>
                       <a:r>
-                        <a:rPr sz="1050" b="0">
+                        <a:rPr sz="1100" b="0">
                           <a:solidFill>
                             <a:srgbClr val="0F172A"/>
                           </a:solidFill>
@@ -26173,7 +25828,7 @@
                     <a:p>
                       <a:pPr algn="r"/>
                       <a:r>
-                        <a:rPr sz="1050" b="0">
+                        <a:rPr sz="1100" b="0">
                           <a:solidFill>
                             <a:srgbClr val="0F172A"/>
                           </a:solidFill>
@@ -26190,7 +25845,7 @@
                   </a:tcPr>
                 </a:tc>
               </a:tr>
-              <a:tr h="347472">
+              <a:tr h="384048">
                 <a:tc>
                   <a:txBody>
                     <a:bodyPr wrap="square"/>
@@ -26198,7 +25853,7 @@
                     <a:p>
                       <a:pPr algn="l"/>
                       <a:r>
-                        <a:rPr sz="1050" b="0">
+                        <a:rPr sz="1100" b="0">
                           <a:solidFill>
                             <a:srgbClr val="0F172A"/>
                           </a:solidFill>
@@ -26221,7 +25876,7 @@
                     <a:p>
                       <a:pPr algn="r"/>
                       <a:r>
-                        <a:rPr sz="1050" b="0">
+                        <a:rPr sz="1100" b="0">
                           <a:solidFill>
                             <a:srgbClr val="0F172A"/>
                           </a:solidFill>
@@ -26244,7 +25899,7 @@
                     <a:p>
                       <a:pPr algn="r"/>
                       <a:r>
-                        <a:rPr sz="1050" b="0">
+                        <a:rPr sz="1100" b="0">
                           <a:solidFill>
                             <a:srgbClr val="0F172A"/>
                           </a:solidFill>
@@ -26267,7 +25922,7 @@
                     <a:p>
                       <a:pPr algn="r"/>
                       <a:r>
-                        <a:rPr sz="1050" b="0">
+                        <a:rPr sz="1100" b="0">
                           <a:solidFill>
                             <a:srgbClr val="0F172A"/>
                           </a:solidFill>
@@ -26290,7 +25945,7 @@
                     <a:p>
                       <a:pPr algn="r"/>
                       <a:r>
-                        <a:rPr sz="1050" b="0">
+                        <a:rPr sz="1100" b="0">
                           <a:solidFill>
                             <a:srgbClr val="0F172A"/>
                           </a:solidFill>
@@ -26313,7 +25968,7 @@
                     <a:p>
                       <a:pPr algn="r"/>
                       <a:r>
-                        <a:rPr sz="1050" b="0">
+                        <a:rPr sz="1100" b="0">
                           <a:solidFill>
                             <a:srgbClr val="0F172A"/>
                           </a:solidFill>
@@ -26336,7 +25991,7 @@
                     <a:p>
                       <a:pPr algn="r"/>
                       <a:r>
-                        <a:rPr sz="1050" b="0">
+                        <a:rPr sz="1100" b="0">
                           <a:solidFill>
                             <a:srgbClr val="0F172A"/>
                           </a:solidFill>
@@ -26353,7 +26008,7 @@
                   </a:tcPr>
                 </a:tc>
               </a:tr>
-              <a:tr h="347472">
+              <a:tr h="384048">
                 <a:tc>
                   <a:txBody>
                     <a:bodyPr wrap="square"/>
@@ -26361,7 +26016,7 @@
                     <a:p>
                       <a:pPr algn="l"/>
                       <a:r>
-                        <a:rPr sz="1050" b="0">
+                        <a:rPr sz="1100" b="0">
                           <a:solidFill>
                             <a:srgbClr val="0F172A"/>
                           </a:solidFill>
@@ -26384,7 +26039,7 @@
                     <a:p>
                       <a:pPr algn="r"/>
                       <a:r>
-                        <a:rPr sz="1050" b="0">
+                        <a:rPr sz="1100" b="0">
                           <a:solidFill>
                             <a:srgbClr val="0F172A"/>
                           </a:solidFill>
@@ -26407,7 +26062,7 @@
                     <a:p>
                       <a:pPr algn="r"/>
                       <a:r>
-                        <a:rPr sz="1050" b="0">
+                        <a:rPr sz="1100" b="0">
                           <a:solidFill>
                             <a:srgbClr val="0F172A"/>
                           </a:solidFill>
@@ -26430,7 +26085,7 @@
                     <a:p>
                       <a:pPr algn="r"/>
                       <a:r>
-                        <a:rPr sz="1050" b="0">
+                        <a:rPr sz="1100" b="0">
                           <a:solidFill>
                             <a:srgbClr val="0F172A"/>
                           </a:solidFill>
@@ -26453,7 +26108,7 @@
                     <a:p>
                       <a:pPr algn="r"/>
                       <a:r>
-                        <a:rPr sz="1050" b="0">
+                        <a:rPr sz="1100" b="0">
                           <a:solidFill>
                             <a:srgbClr val="0F172A"/>
                           </a:solidFill>
@@ -26476,7 +26131,7 @@
                     <a:p>
                       <a:pPr algn="r"/>
                       <a:r>
-                        <a:rPr sz="1050" b="0">
+                        <a:rPr sz="1100" b="0">
                           <a:solidFill>
                             <a:srgbClr val="0F172A"/>
                           </a:solidFill>
@@ -26499,7 +26154,7 @@
                     <a:p>
                       <a:pPr algn="r"/>
                       <a:r>
-                        <a:rPr sz="1050" b="0">
+                        <a:rPr sz="1100" b="0">
                           <a:solidFill>
                             <a:srgbClr val="0F172A"/>
                           </a:solidFill>
@@ -26516,7 +26171,7 @@
                   </a:tcPr>
                 </a:tc>
               </a:tr>
-              <a:tr h="347472">
+              <a:tr h="384048">
                 <a:tc>
                   <a:txBody>
                     <a:bodyPr wrap="square"/>
@@ -26524,7 +26179,7 @@
                     <a:p>
                       <a:pPr algn="l"/>
                       <a:r>
-                        <a:rPr sz="1050" b="0">
+                        <a:rPr sz="1100" b="0">
                           <a:solidFill>
                             <a:srgbClr val="0F172A"/>
                           </a:solidFill>
@@ -26547,7 +26202,7 @@
                     <a:p>
                       <a:pPr algn="r"/>
                       <a:r>
-                        <a:rPr sz="1050" b="0">
+                        <a:rPr sz="1100" b="0">
                           <a:solidFill>
                             <a:srgbClr val="0F172A"/>
                           </a:solidFill>
@@ -26570,7 +26225,7 @@
                     <a:p>
                       <a:pPr algn="r"/>
                       <a:r>
-                        <a:rPr sz="1050" b="0">
+                        <a:rPr sz="1100" b="0">
                           <a:solidFill>
                             <a:srgbClr val="0F172A"/>
                           </a:solidFill>
@@ -26593,7 +26248,7 @@
                     <a:p>
                       <a:pPr algn="r"/>
                       <a:r>
-                        <a:rPr sz="1050" b="0">
+                        <a:rPr sz="1100" b="0">
                           <a:solidFill>
                             <a:srgbClr val="0F172A"/>
                           </a:solidFill>
@@ -26616,7 +26271,7 @@
                     <a:p>
                       <a:pPr algn="r"/>
                       <a:r>
-                        <a:rPr sz="1050" b="0">
+                        <a:rPr sz="1100" b="0">
                           <a:solidFill>
                             <a:srgbClr val="0F172A"/>
                           </a:solidFill>
@@ -26639,7 +26294,7 @@
                     <a:p>
                       <a:pPr algn="r"/>
                       <a:r>
-                        <a:rPr sz="1050" b="0">
+                        <a:rPr sz="1100" b="0">
                           <a:solidFill>
                             <a:srgbClr val="0F172A"/>
                           </a:solidFill>
@@ -26662,7 +26317,7 @@
                     <a:p>
                       <a:pPr algn="r"/>
                       <a:r>
-                        <a:rPr sz="1050" b="0">
+                        <a:rPr sz="1100" b="0">
                           <a:solidFill>
                             <a:srgbClr val="0F172A"/>
                           </a:solidFill>
@@ -26686,161 +26341,13 @@
       <p:sp>
         <p:nvSpPr>
           <p:cNvPr id="11" name=""/>
-          <p:cNvSpPr/>
-          <p:nvPr/>
-        </p:nvSpPr>
-        <p:spPr>
-          <a:xfrm>
-            <a:off x="7543800" y="1417320"/>
-            <a:ext cx="4096512" cy="4800600"/>
-          </a:xfrm>
-          <a:prstGeom prst="roundRect">
-            <a:avLst>
-              <a:gd name="" fmla="val 6000"/>
-            </a:avLst>
-          </a:prstGeom>
-          <a:solidFill>
-            <a:srgbClr val="FFFFFF"/>
-          </a:solidFill>
-          <a:ln w="9525">
-            <a:solidFill>
-              <a:srgbClr val="E5E0D6"/>
-            </a:solidFill>
-          </a:ln>
-        </p:spPr>
-      </p:sp>
-      <p:sp>
-        <p:nvSpPr>
-          <p:cNvPr id="12" name=""/>
-          <p:cNvSpPr txBox="1"/>
-          <p:nvPr/>
-        </p:nvSpPr>
-        <p:spPr>
-          <a:xfrm>
-            <a:off x="7726679" y="1554480"/>
-            <a:ext cx="3730752" cy="274320"/>
-          </a:xfrm>
-          <a:prstGeom prst="rect">
-            <a:avLst/>
-          </a:prstGeom>
-          <a:noFill/>
-        </p:spPr>
-        <p:txBody>
-          <a:bodyPr wrap="square" lIns="36576" rIns="36576" tIns="18288" bIns="18288" anchor="t">
-            <a:spAutoFit/>
-          </a:bodyPr>
-          <a:lstStyle/>
-          <a:p>
-            <a:pPr algn="l"/>
-            <a:r>
-              <a:rPr sz="1200" b="1">
-                <a:solidFill>
-                  <a:srgbClr val="0F172A"/>
-                </a:solidFill>
-                <a:latin typeface="Space Grotesk"/>
-              </a:rPr>
-              <a:t>Read-out</a:t>
-            </a:r>
-          </a:p>
-        </p:txBody>
-      </p:sp>
-      <p:sp>
-        <p:nvSpPr>
-          <p:cNvPr id="13" name=""/>
-          <p:cNvSpPr txBox="1"/>
-          <p:nvPr/>
-        </p:nvSpPr>
-        <p:spPr>
-          <a:xfrm>
-            <a:off x="7726679" y="1874519"/>
-            <a:ext cx="3730752" cy="4251960"/>
-          </a:xfrm>
-          <a:prstGeom prst="rect">
-            <a:avLst/>
-          </a:prstGeom>
-          <a:noFill/>
-        </p:spPr>
-        <p:txBody>
-          <a:bodyPr wrap="square" lIns="36576" rIns="36576" tIns="18288" bIns="18288" anchor="t">
-            <a:spAutoFit/>
-          </a:bodyPr>
-          <a:lstStyle/>
-          <a:p>
-            <a:pPr algn="l">
-              <a:spcAft>
-                <a:spcPts val="500"/>
-              </a:spcAft>
-            </a:pPr>
-            <a:r>
-              <a:rPr sz="1050" b="0">
-                <a:solidFill>
-                  <a:srgbClr val="334155"/>
-                </a:solidFill>
-                <a:latin typeface="Inter"/>
-              </a:rPr>
-              <a:t>Non-branded searches are the expensive side of the account: category keywords ran at 39.7% ACoS this week vs 16.7% for branded.</a:t>
-            </a:r>
-          </a:p>
-          <a:p>
-            <a:pPr algn="l">
-              <a:spcAft>
-                <a:spcPts val="500"/>
-              </a:spcAft>
-            </a:pPr>
-            <a:r>
-              <a:rPr sz="1050" b="0">
-                <a:solidFill>
-                  <a:srgbClr val="334155"/>
-                </a:solidFill>
-                <a:latin typeface="Inter"/>
-              </a:rPr>
-              <a:t>The generic “mattress +topper” phrase target alone spent $1,191 for 4 orders (73.6% ACoS).</a:t>
-            </a:r>
-          </a:p>
-          <a:p>
-            <a:pPr algn="l">
-              <a:spcAft>
-                <a:spcPts val="500"/>
-              </a:spcAft>
-            </a:pPr>
-            <a:r>
-              <a:rPr sz="1050" b="0">
-                <a:solidFill>
-                  <a:srgbClr val="334155"/>
-                </a:solidFill>
-                <a:latin typeface="Inter"/>
-              </a:rPr>
-              <a:t>The searches that did convert are size-specific (“bed toppers queen size”, “split king”, “short king”). Move budget toward size-specific exact keywords and away from the broad generic phrase.</a:t>
-            </a:r>
-          </a:p>
-          <a:p>
-            <a:pPr algn="l">
-              <a:spcAft>
-                <a:spcPts val="500"/>
-              </a:spcAft>
-            </a:pPr>
-            <a:r>
-              <a:rPr sz="1050" b="0">
-                <a:solidFill>
-                  <a:srgbClr val="334155"/>
-                </a:solidFill>
-                <a:latin typeface="Inter"/>
-              </a:rPr>
-              <a:t>3 converting searches are ready to add as exact keywords; 19 are candidates for negatives.</a:t>
-            </a:r>
-          </a:p>
-        </p:txBody>
-      </p:sp>
-      <p:sp>
-        <p:nvSpPr>
-          <p:cNvPr id="14" name=""/>
-          <p:cNvSpPr txBox="1"/>
-          <p:nvPr/>
-        </p:nvSpPr>
-        <p:spPr>
-          <a:xfrm>
-            <a:off x="548640" y="3593592"/>
-            <a:ext cx="6766560" cy="457200"/>
+          <p:cNvSpPr txBox="1"/>
+          <p:nvPr/>
+        </p:nvSpPr>
+        <p:spPr>
+          <a:xfrm>
+            <a:off x="548640" y="3858768"/>
+            <a:ext cx="11091672" cy="457200"/>
           </a:xfrm>
           <a:prstGeom prst="rect">
             <a:avLst/>

</xml_diff>

<commit_message>
Dormeo US weekly deck: week 43 inventory slide from the sheet
Co-Authored-By: Claude Opus 5.5 <noreply@anthropic.com>
Claude-Session: https://claude.ai/code/session_01RHhJWYgzkcDa1EG1ieFn7V
</commit_message>
<xml_diff>
--- a/dormeo-us/deck/2026-10-24/Dormeo-US-Weekly-Business-Review-Week-43-2026-10-24.pptx
+++ b/dormeo-us/deck/2026-10-24/Dormeo-US-Weekly-Business-Review-Week-43-2026-10-24.pptx
@@ -7005,7 +7005,7 @@
                 </a:solidFill>
                 <a:latin typeface="Space Grotesk"/>
               </a:rPr>
-              <a:t>2</a:t>
+              <a:t>4</a:t>
             </a:r>
           </a:p>
         </p:txBody>
@@ -7040,7 +7040,7 @@
                 </a:solidFill>
                 <a:latin typeface="Inter"/>
               </a:rPr>
-              <a:t>selling ASINs at 0 units</a:t>
+              <a:t>of 19 selling SKUs, 0 at FBA</a:t>
             </a:r>
           </a:p>
         </p:txBody>
@@ -7134,7 +7134,7 @@
                 </a:solidFill>
                 <a:latin typeface="Space Grotesk"/>
               </a:rPr>
-              <a:t>6</a:t>
+              <a:t>2</a:t>
             </a:r>
           </a:p>
         </p:txBody>
@@ -7169,7 +7169,7 @@
                 </a:solidFill>
                 <a:latin typeface="Inter"/>
               </a:rPr>
-              <a:t>under ~30 days of supply</a:t>
+              <a:t>4 weeks of stock or less</a:t>
             </a:r>
           </a:p>
         </p:txBody>
@@ -7228,7 +7228,7 @@
                 </a:solidFill>
                 <a:latin typeface="Inter"/>
               </a:rPr>
-              <a:t>FLAGGED BY SELLERISE</a:t>
+              <a:t>UNITS INBOUND</a:t>
             </a:r>
           </a:p>
         </p:txBody>
@@ -7263,7 +7263,7 @@
                 </a:solidFill>
                 <a:latin typeface="Space Grotesk"/>
               </a:rPr>
-              <a:t>27</a:t>
+              <a:t>938</a:t>
             </a:r>
           </a:p>
         </p:txBody>
@@ -7298,7 +7298,7 @@
                 </a:solidFill>
                 <a:latin typeface="Inter"/>
               </a:rPr>
-              <a:t>ASINs with an inventory risk</a:t>
+              <a:t>on the way to FBA</a:t>
             </a:r>
           </a:p>
         </p:txBody>

</xml_diff>